<commit_message>
fix: harden preview package after independent review
</commit_message>
<xml_diff>
--- a/hermes_docs/OCI_Integrated_Sales_Platform_Planning_v2.pptx
+++ b/hermes_docs/OCI_Integrated_Sales_Platform_Planning_v2.pptx
@@ -11861,7 +11861,7 @@
                 <a:ea typeface="Noto Sans KR" pitchFamily="34" charset="-122"/>
                 <a:cs typeface="Noto Sans KR" pitchFamily="34" charset="-120"/>
               </a:rPr>
-              <a:t>App · DDL · release/rollback</a:t>
+              <a:t>Preview app · DDL · rollback</a:t>
             </a:r>
             <a:endParaRPr lang="en-US" sz="1020" dirty="0"/>
           </a:p>
@@ -12215,7 +12215,7 @@
                 <a:ea typeface="Noto Sans KR" pitchFamily="34" charset="-122"/>
                 <a:cs typeface="Noto Sans KR" pitchFamily="34" charset="-120"/>
               </a:rPr>
-              <a:t>HERMESUSER credential + schema scope</a:t>
+              <a:t>credential · schema · Oracle adapter</a:t>
             </a:r>
             <a:endParaRPr lang="en-US" sz="1020" dirty="0"/>
           </a:p>

</xml_diff>